<commit_message>
HR slide: replace interview questions with the executive board
Co-Authored-By: Claude Opus 5.5 <noreply@anthropic.com>
Claude-Session: https://claude.ai/code/session_01TFmXfwWy7YkFL9ETqt4WJz
</commit_message>
<xml_diff>
--- a/HR-slide.pptx
+++ b/HR-slide.pptx
@@ -502,7 +502,7 @@
           <a:p>
             <a:r>
               <a:rPr lang="en-US" dirty="0"/>
-              <a:t>As HR Manager, my job is to find the right people for NutriPill and keep them motivated. Our hiring process has three steps. First, you apply by sending your CV and a short video explaining why you want to join us. Second, we do a live interview. It's not just about your CV; we want to see how you deal with pressure and how you work in a team. For example, we ask questions like: How would you react if a deadline was suddenly moved forward? Or: How would you deal with an unhappy customer? Finally, there's a trial day, so you can work with the team before we both decide. In return, we offer training, flexible hours, fair pay and, of course, respect for everyone in the team.</a:t>
+              <a:t>As HR Manager, my job is to find the right people for NutriPill and keep them motivated. Our hiring process has three steps. First, you apply by sending your CV and a short video explaining why you want to join us. Second, we do a live interview. It's not just about your CV; we want to see how you deal with pressure and how you work in a team. Finally, there's a trial day, so you can work with the team before we both decide. Right now, our team is the four of us: Miguel is our CEO and leads the company, Dani is our CMO and runs the marketing, Max is our CFO and manages the money, and I'm the HR Manager. In return for their hard work, we offer our team training, flexible hours, fair pay and, of course, respect for everyone.</a:t>
             </a:r>
             <a:endParaRPr lang="en-US" dirty="0"/>
           </a:p>
@@ -1903,7 +1903,7 @@
                 <a:ea typeface="Calibri" pitchFamily="34" charset="-122"/>
                 <a:cs typeface="Calibri" pitchFamily="34" charset="-120"/>
               </a:rPr>
-              <a:t>QUESTIONS WE ASK IN INTERVIEWS</a:t>
+              <a:t>OUR EXECUTIVE BOARD</a:t>
             </a:r>
             <a:endParaRPr lang="en-US" sz="1300" dirty="0"/>
           </a:p>
@@ -1917,28 +1917,52 @@
         </p:nvSpPr>
         <p:spPr>
           <a:xfrm>
-            <a:off x="6675120" y="3108960"/>
+            <a:off x="6675120" y="3063240"/>
             <a:ext cx="502920" cy="502920"/>
           </a:xfrm>
           <a:prstGeom prst="ellipse">
             <a:avLst/>
           </a:prstGeom>
           <a:solidFill>
-            <a:srgbClr val="FFF0EC"/>
+            <a:srgbClr val="0B1F3A"/>
           </a:solidFill>
           <a:ln/>
         </p:spPr>
       </p:sp>
+      <p:pic>
+        <p:nvPicPr>
+          <p:cNvPr id="21" name="a7_icon" descr="CEO">    </p:cNvPr>
+          <p:cNvPicPr>
+            <a:picLocks noChangeAspect="1"/>
+          </p:cNvPicPr>
+          <p:nvPr/>
+        </p:nvPicPr>
+        <p:blipFill>
+          <a:blip r:embed="rId4"/>
+          <a:stretch>
+            <a:fillRect/>
+          </a:stretch>
+        </p:blipFill>
+        <p:spPr>
+          <a:xfrm>
+            <a:off x="6812280" y="3200400"/>
+            <a:ext cx="228600" cy="228600"/>
+          </a:xfrm>
+          <a:prstGeom prst="rect">
+            <a:avLst/>
+          </a:prstGeom>
+        </p:spPr>
+      </p:pic>
       <p:sp>
         <p:nvSpPr>
-          <p:cNvPr id="21" name="a7_q"/>
+          <p:cNvPr id="22" name="a7_n"/>
           <p:cNvSpPr txBox="1"/>
           <p:nvPr/>
         </p:nvSpPr>
         <p:spPr>
           <a:xfrm>
-            <a:off x="6675120" y="3108960"/>
-            <a:ext cx="502920" cy="502920"/>
+            <a:off x="7360920" y="2999232"/>
+            <a:ext cx="4023360" cy="320040"/>
           </a:xfrm>
           <a:prstGeom prst="rect">
             <a:avLst/>
@@ -1947,37 +1971,51 @@
           <a:ln/>
         </p:spPr>
         <p:txBody>
-          <a:bodyPr wrap="square" lIns="0" tIns="0" rIns="0" bIns="0" rtlCol="0" anchor="ctr"/>
+          <a:bodyPr wrap="square" lIns="0" tIns="0" rIns="0" bIns="0" rtlCol="0" anchor="t"/>
           <a:lstStyle/>
           <a:p>
-            <a:pPr algn="ctr" indent="0" marL="0">
+            <a:pPr indent="0" marL="0">
               <a:buNone/>
             </a:pPr>
             <a:r>
-              <a:rPr lang="en-US" sz="1800" b="1" dirty="0">
+              <a:rPr lang="en-US" sz="1600" b="1" dirty="0">
                 <a:solidFill>
-                  <a:srgbClr val="FF6B4A"/>
+                  <a:srgbClr val="0B1F3A"/>
                 </a:solidFill>
                 <a:latin typeface="Calibri" pitchFamily="34" charset="0"/>
                 <a:ea typeface="Calibri" pitchFamily="34" charset="-122"/>
                 <a:cs typeface="Calibri" pitchFamily="34" charset="-120"/>
               </a:rPr>
-              <a:t>?</a:t>
+              <a:t>Miguel</a:t>
             </a:r>
-            <a:endParaRPr lang="en-US" sz="1800" dirty="0"/>
+            <a:pPr indent="0" marL="0">
+              <a:buNone/>
+            </a:pPr>
+            <a:r>
+              <a:rPr lang="en-US" sz="1600" b="1" dirty="0">
+                <a:solidFill>
+                  <a:srgbClr val="14C9A1"/>
+                </a:solidFill>
+                <a:latin typeface="Calibri" pitchFamily="34" charset="0"/>
+                <a:ea typeface="Calibri" pitchFamily="34" charset="-122"/>
+                <a:cs typeface="Calibri" pitchFamily="34" charset="-120"/>
+              </a:rPr>
+              <a:t>  ·  CEO</a:t>
+            </a:r>
+            <a:endParaRPr lang="en-US" sz="1600" dirty="0"/>
           </a:p>
         </p:txBody>
       </p:sp>
       <p:sp>
         <p:nvSpPr>
-          <p:cNvPr id="22" name="a7_t"/>
+          <p:cNvPr id="23" name="a7_d"/>
           <p:cNvSpPr txBox="1"/>
           <p:nvPr/>
         </p:nvSpPr>
         <p:spPr>
           <a:xfrm>
-            <a:off x="7360920" y="3063240"/>
-            <a:ext cx="3977640" cy="685800"/>
+            <a:off x="7360920" y="3319272"/>
+            <a:ext cx="4023360" cy="292608"/>
           </a:xfrm>
           <a:prstGeom prst="rect">
             <a:avLst/>
@@ -1986,57 +2024,81 @@
           <a:ln/>
         </p:spPr>
         <p:txBody>
-          <a:bodyPr wrap="square" lIns="0" tIns="0" rIns="0" bIns="0" rtlCol="0" anchor="ctr"/>
+          <a:bodyPr wrap="square" lIns="0" tIns="0" rIns="0" bIns="0" rtlCol="0" anchor="t"/>
           <a:lstStyle/>
           <a:p>
             <a:pPr indent="0" marL="0">
               <a:buNone/>
             </a:pPr>
             <a:r>
-              <a:rPr lang="en-US" sz="1500" i="1" dirty="0">
+              <a:rPr lang="en-US" sz="1400" dirty="0">
                 <a:solidFill>
-                  <a:srgbClr val="0B1F3A"/>
+                  <a:srgbClr val="5B6B80"/>
                 </a:solidFill>
                 <a:latin typeface="Calibri" pitchFamily="34" charset="0"/>
                 <a:ea typeface="Calibri" pitchFamily="34" charset="-122"/>
                 <a:cs typeface="Calibri" pitchFamily="34" charset="-120"/>
               </a:rPr>
-              <a:t>“How would you react if a deadline was suddenly moved forward?”</a:t>
+              <a:t>Leads the pitch and the company's vision</a:t>
             </a:r>
-            <a:endParaRPr lang="en-US" sz="1500" dirty="0"/>
+            <a:endParaRPr lang="en-US" sz="1400" dirty="0"/>
           </a:p>
         </p:txBody>
       </p:sp>
       <p:sp>
         <p:nvSpPr>
-          <p:cNvPr id="23" name="a8_dot"/>
+          <p:cNvPr id="24" name="a8_dot"/>
           <p:cNvSpPr/>
           <p:nvPr/>
         </p:nvSpPr>
         <p:spPr>
           <a:xfrm>
-            <a:off x="6675120" y="3977640"/>
+            <a:off x="6675120" y="3749040"/>
             <a:ext cx="502920" cy="502920"/>
           </a:xfrm>
           <a:prstGeom prst="ellipse">
             <a:avLst/>
           </a:prstGeom>
           <a:solidFill>
-            <a:srgbClr val="FFF0EC"/>
+            <a:srgbClr val="0B1F3A"/>
           </a:solidFill>
           <a:ln/>
         </p:spPr>
       </p:sp>
+      <p:pic>
+        <p:nvPicPr>
+          <p:cNvPr id="25" name="a8_icon" descr="CMO">    </p:cNvPr>
+          <p:cNvPicPr>
+            <a:picLocks noChangeAspect="1"/>
+          </p:cNvPicPr>
+          <p:nvPr/>
+        </p:nvPicPr>
+        <p:blipFill>
+          <a:blip r:embed="rId5"/>
+          <a:stretch>
+            <a:fillRect/>
+          </a:stretch>
+        </p:blipFill>
+        <p:spPr>
+          <a:xfrm>
+            <a:off x="6812280" y="3886200"/>
+            <a:ext cx="228600" cy="228600"/>
+          </a:xfrm>
+          <a:prstGeom prst="rect">
+            <a:avLst/>
+          </a:prstGeom>
+        </p:spPr>
+      </p:pic>
       <p:sp>
         <p:nvSpPr>
-          <p:cNvPr id="24" name="a8_q"/>
+          <p:cNvPr id="26" name="a8_n"/>
           <p:cNvSpPr txBox="1"/>
           <p:nvPr/>
         </p:nvSpPr>
         <p:spPr>
           <a:xfrm>
-            <a:off x="6675120" y="3977640"/>
-            <a:ext cx="502920" cy="502920"/>
+            <a:off x="7360920" y="3685032"/>
+            <a:ext cx="4023360" cy="320040"/>
           </a:xfrm>
           <a:prstGeom prst="rect">
             <a:avLst/>
@@ -2045,37 +2107,51 @@
           <a:ln/>
         </p:spPr>
         <p:txBody>
-          <a:bodyPr wrap="square" lIns="0" tIns="0" rIns="0" bIns="0" rtlCol="0" anchor="ctr"/>
+          <a:bodyPr wrap="square" lIns="0" tIns="0" rIns="0" bIns="0" rtlCol="0" anchor="t"/>
           <a:lstStyle/>
           <a:p>
-            <a:pPr algn="ctr" indent="0" marL="0">
+            <a:pPr indent="0" marL="0">
               <a:buNone/>
             </a:pPr>
             <a:r>
-              <a:rPr lang="en-US" sz="1800" b="1" dirty="0">
+              <a:rPr lang="en-US" sz="1600" b="1" dirty="0">
                 <a:solidFill>
-                  <a:srgbClr val="FF6B4A"/>
+                  <a:srgbClr val="0B1F3A"/>
                 </a:solidFill>
                 <a:latin typeface="Calibri" pitchFamily="34" charset="0"/>
                 <a:ea typeface="Calibri" pitchFamily="34" charset="-122"/>
                 <a:cs typeface="Calibri" pitchFamily="34" charset="-120"/>
               </a:rPr>
-              <a:t>?</a:t>
+              <a:t>Dani</a:t>
             </a:r>
-            <a:endParaRPr lang="en-US" sz="1800" dirty="0"/>
+            <a:pPr indent="0" marL="0">
+              <a:buNone/>
+            </a:pPr>
+            <a:r>
+              <a:rPr lang="en-US" sz="1600" b="1" dirty="0">
+                <a:solidFill>
+                  <a:srgbClr val="14C9A1"/>
+                </a:solidFill>
+                <a:latin typeface="Calibri" pitchFamily="34" charset="0"/>
+                <a:ea typeface="Calibri" pitchFamily="34" charset="-122"/>
+                <a:cs typeface="Calibri" pitchFamily="34" charset="-120"/>
+              </a:rPr>
+              <a:t>  ·  CMO</a:t>
+            </a:r>
+            <a:endParaRPr lang="en-US" sz="1600" dirty="0"/>
           </a:p>
         </p:txBody>
       </p:sp>
       <p:sp>
         <p:nvSpPr>
-          <p:cNvPr id="25" name="a8_t"/>
+          <p:cNvPr id="27" name="a8_d"/>
           <p:cNvSpPr txBox="1"/>
           <p:nvPr/>
         </p:nvSpPr>
         <p:spPr>
           <a:xfrm>
-            <a:off x="7360920" y="3931920"/>
-            <a:ext cx="3977640" cy="685800"/>
+            <a:off x="7360920" y="4005072"/>
+            <a:ext cx="4023360" cy="292608"/>
           </a:xfrm>
           <a:prstGeom prst="rect">
             <a:avLst/>
@@ -2084,57 +2160,81 @@
           <a:ln/>
         </p:spPr>
         <p:txBody>
-          <a:bodyPr wrap="square" lIns="0" tIns="0" rIns="0" bIns="0" rtlCol="0" anchor="ctr"/>
+          <a:bodyPr wrap="square" lIns="0" tIns="0" rIns="0" bIns="0" rtlCol="0" anchor="t"/>
           <a:lstStyle/>
           <a:p>
             <a:pPr indent="0" marL="0">
               <a:buNone/>
             </a:pPr>
             <a:r>
-              <a:rPr lang="en-US" sz="1500" i="1" dirty="0">
+              <a:rPr lang="en-US" sz="1400" dirty="0">
                 <a:solidFill>
-                  <a:srgbClr val="0B1F3A"/>
+                  <a:srgbClr val="5B6B80"/>
                 </a:solidFill>
                 <a:latin typeface="Calibri" pitchFamily="34" charset="0"/>
                 <a:ea typeface="Calibri" pitchFamily="34" charset="-122"/>
                 <a:cs typeface="Calibri" pitchFamily="34" charset="-120"/>
               </a:rPr>
-              <a:t>“What would you do if a teammate made a big mistake?”</a:t>
+              <a:t>Runs our advertising and market research</a:t>
             </a:r>
-            <a:endParaRPr lang="en-US" sz="1500" dirty="0"/>
+            <a:endParaRPr lang="en-US" sz="1400" dirty="0"/>
           </a:p>
         </p:txBody>
       </p:sp>
       <p:sp>
         <p:nvSpPr>
-          <p:cNvPr id="26" name="a9_dot"/>
+          <p:cNvPr id="28" name="a9_dot"/>
           <p:cNvSpPr/>
           <p:nvPr/>
         </p:nvSpPr>
         <p:spPr>
           <a:xfrm>
-            <a:off x="6675120" y="4846320"/>
+            <a:off x="6675120" y="4434840"/>
             <a:ext cx="502920" cy="502920"/>
           </a:xfrm>
           <a:prstGeom prst="ellipse">
             <a:avLst/>
           </a:prstGeom>
           <a:solidFill>
-            <a:srgbClr val="FFF0EC"/>
+            <a:srgbClr val="0B1F3A"/>
           </a:solidFill>
           <a:ln/>
         </p:spPr>
       </p:sp>
+      <p:pic>
+        <p:nvPicPr>
+          <p:cNvPr id="29" name="a9_icon" descr="CFO">    </p:cNvPr>
+          <p:cNvPicPr>
+            <a:picLocks noChangeAspect="1"/>
+          </p:cNvPicPr>
+          <p:nvPr/>
+        </p:nvPicPr>
+        <p:blipFill>
+          <a:blip r:embed="rId6"/>
+          <a:stretch>
+            <a:fillRect/>
+          </a:stretch>
+        </p:blipFill>
+        <p:spPr>
+          <a:xfrm>
+            <a:off x="6812280" y="4572000"/>
+            <a:ext cx="228600" cy="228600"/>
+          </a:xfrm>
+          <a:prstGeom prst="rect">
+            <a:avLst/>
+          </a:prstGeom>
+        </p:spPr>
+      </p:pic>
       <p:sp>
         <p:nvSpPr>
-          <p:cNvPr id="27" name="a9_q"/>
+          <p:cNvPr id="30" name="a9_n"/>
           <p:cNvSpPr txBox="1"/>
           <p:nvPr/>
         </p:nvSpPr>
         <p:spPr>
           <a:xfrm>
-            <a:off x="6675120" y="4846320"/>
-            <a:ext cx="502920" cy="502920"/>
+            <a:off x="7360920" y="4370832"/>
+            <a:ext cx="4023360" cy="320040"/>
           </a:xfrm>
           <a:prstGeom prst="rect">
             <a:avLst/>
@@ -2143,37 +2243,51 @@
           <a:ln/>
         </p:spPr>
         <p:txBody>
-          <a:bodyPr wrap="square" lIns="0" tIns="0" rIns="0" bIns="0" rtlCol="0" anchor="ctr"/>
+          <a:bodyPr wrap="square" lIns="0" tIns="0" rIns="0" bIns="0" rtlCol="0" anchor="t"/>
           <a:lstStyle/>
           <a:p>
-            <a:pPr algn="ctr" indent="0" marL="0">
+            <a:pPr indent="0" marL="0">
               <a:buNone/>
             </a:pPr>
             <a:r>
-              <a:rPr lang="en-US" sz="1800" b="1" dirty="0">
+              <a:rPr lang="en-US" sz="1600" b="1" dirty="0">
                 <a:solidFill>
-                  <a:srgbClr val="FF6B4A"/>
+                  <a:srgbClr val="0B1F3A"/>
                 </a:solidFill>
                 <a:latin typeface="Calibri" pitchFamily="34" charset="0"/>
                 <a:ea typeface="Calibri" pitchFamily="34" charset="-122"/>
                 <a:cs typeface="Calibri" pitchFamily="34" charset="-120"/>
               </a:rPr>
-              <a:t>?</a:t>
+              <a:t>Max</a:t>
             </a:r>
-            <a:endParaRPr lang="en-US" sz="1800" dirty="0"/>
+            <a:pPr indent="0" marL="0">
+              <a:buNone/>
+            </a:pPr>
+            <a:r>
+              <a:rPr lang="en-US" sz="1600" b="1" dirty="0">
+                <a:solidFill>
+                  <a:srgbClr val="14C9A1"/>
+                </a:solidFill>
+                <a:latin typeface="Calibri" pitchFamily="34" charset="0"/>
+                <a:ea typeface="Calibri" pitchFamily="34" charset="-122"/>
+                <a:cs typeface="Calibri" pitchFamily="34" charset="-120"/>
+              </a:rPr>
+              <a:t>  ·  CFO</a:t>
+            </a:r>
+            <a:endParaRPr lang="en-US" sz="1600" dirty="0"/>
           </a:p>
         </p:txBody>
       </p:sp>
       <p:sp>
         <p:nvSpPr>
-          <p:cNvPr id="28" name="a9_t"/>
+          <p:cNvPr id="31" name="a9_d"/>
           <p:cNvSpPr txBox="1"/>
           <p:nvPr/>
         </p:nvSpPr>
         <p:spPr>
           <a:xfrm>
-            <a:off x="7360920" y="4800600"/>
-            <a:ext cx="3977640" cy="685800"/>
+            <a:off x="7360920" y="4690872"/>
+            <a:ext cx="4023360" cy="292608"/>
           </a:xfrm>
           <a:prstGeom prst="rect">
             <a:avLst/>
@@ -2182,14 +2296,97 @@
           <a:ln/>
         </p:spPr>
         <p:txBody>
-          <a:bodyPr wrap="square" lIns="0" tIns="0" rIns="0" bIns="0" rtlCol="0" anchor="ctr"/>
+          <a:bodyPr wrap="square" lIns="0" tIns="0" rIns="0" bIns="0" rtlCol="0" anchor="t"/>
           <a:lstStyle/>
           <a:p>
             <a:pPr indent="0" marL="0">
               <a:buNone/>
             </a:pPr>
             <a:r>
-              <a:rPr lang="en-US" sz="1500" i="1" dirty="0">
+              <a:rPr lang="en-US" sz="1400" dirty="0">
+                <a:solidFill>
+                  <a:srgbClr val="5B6B80"/>
+                </a:solidFill>
+                <a:latin typeface="Calibri" pitchFamily="34" charset="0"/>
+                <a:ea typeface="Calibri" pitchFamily="34" charset="-122"/>
+                <a:cs typeface="Calibri" pitchFamily="34" charset="-120"/>
+              </a:rPr>
+              <a:t>Manages costs, prices and finances</a:t>
+            </a:r>
+            <a:endParaRPr lang="en-US" sz="1400" dirty="0"/>
+          </a:p>
+        </p:txBody>
+      </p:sp>
+      <p:sp>
+        <p:nvSpPr>
+          <p:cNvPr id="32" name="a10_dot"/>
+          <p:cNvSpPr/>
+          <p:nvPr/>
+        </p:nvSpPr>
+        <p:spPr>
+          <a:xfrm>
+            <a:off x="6675120" y="5120640"/>
+            <a:ext cx="502920" cy="502920"/>
+          </a:xfrm>
+          <a:prstGeom prst="ellipse">
+            <a:avLst/>
+          </a:prstGeom>
+          <a:solidFill>
+            <a:srgbClr val="FF6B4A"/>
+          </a:solidFill>
+          <a:ln/>
+        </p:spPr>
+      </p:sp>
+      <p:pic>
+        <p:nvPicPr>
+          <p:cNvPr id="33" name="a10_icon" descr="HR Manager">    </p:cNvPr>
+          <p:cNvPicPr>
+            <a:picLocks noChangeAspect="1"/>
+          </p:cNvPicPr>
+          <p:nvPr/>
+        </p:nvPicPr>
+        <p:blipFill>
+          <a:blip r:embed="rId7"/>
+          <a:stretch>
+            <a:fillRect/>
+          </a:stretch>
+        </p:blipFill>
+        <p:spPr>
+          <a:xfrm>
+            <a:off x="6812280" y="5257800"/>
+            <a:ext cx="228600" cy="228600"/>
+          </a:xfrm>
+          <a:prstGeom prst="rect">
+            <a:avLst/>
+          </a:prstGeom>
+        </p:spPr>
+      </p:pic>
+      <p:sp>
+        <p:nvSpPr>
+          <p:cNvPr id="34" name="a10_n"/>
+          <p:cNvSpPr txBox="1"/>
+          <p:nvPr/>
+        </p:nvSpPr>
+        <p:spPr>
+          <a:xfrm>
+            <a:off x="7360920" y="5056632"/>
+            <a:ext cx="4023360" cy="320040"/>
+          </a:xfrm>
+          <a:prstGeom prst="rect">
+            <a:avLst/>
+          </a:prstGeom>
+          <a:noFill/>
+          <a:ln/>
+        </p:spPr>
+        <p:txBody>
+          <a:bodyPr wrap="square" lIns="0" tIns="0" rIns="0" bIns="0" rtlCol="0" anchor="t"/>
+          <a:lstStyle/>
+          <a:p>
+            <a:pPr indent="0" marL="0">
+              <a:buNone/>
+            </a:pPr>
+            <a:r>
+              <a:rPr lang="en-US" sz="1600" b="1" dirty="0">
                 <a:solidFill>
                   <a:srgbClr val="0B1F3A"/>
                 </a:solidFill>
@@ -2197,15 +2394,68 @@
                 <a:ea typeface="Calibri" pitchFamily="34" charset="-122"/>
                 <a:cs typeface="Calibri" pitchFamily="34" charset="-120"/>
               </a:rPr>
-              <a:t>“How would you deal with an unhappy customer?”</a:t>
+              <a:t>William</a:t>
             </a:r>
-            <a:endParaRPr lang="en-US" sz="1500" dirty="0"/>
+            <a:pPr indent="0" marL="0">
+              <a:buNone/>
+            </a:pPr>
+            <a:r>
+              <a:rPr lang="en-US" sz="1600" b="1" dirty="0">
+                <a:solidFill>
+                  <a:srgbClr val="14C9A1"/>
+                </a:solidFill>
+                <a:latin typeface="Calibri" pitchFamily="34" charset="0"/>
+                <a:ea typeface="Calibri" pitchFamily="34" charset="-122"/>
+                <a:cs typeface="Calibri" pitchFamily="34" charset="-120"/>
+              </a:rPr>
+              <a:t>  ·  HR Manager</a:t>
+            </a:r>
+            <a:endParaRPr lang="en-US" sz="1600" dirty="0"/>
           </a:p>
         </p:txBody>
       </p:sp>
       <p:sp>
         <p:nvSpPr>
-          <p:cNvPr id="29" name="a10_h"/>
+          <p:cNvPr id="35" name="a10_d"/>
+          <p:cNvSpPr txBox="1"/>
+          <p:nvPr/>
+        </p:nvSpPr>
+        <p:spPr>
+          <a:xfrm>
+            <a:off x="7360920" y="5376672"/>
+            <a:ext cx="4023360" cy="292608"/>
+          </a:xfrm>
+          <a:prstGeom prst="rect">
+            <a:avLst/>
+          </a:prstGeom>
+          <a:noFill/>
+          <a:ln/>
+        </p:spPr>
+        <p:txBody>
+          <a:bodyPr wrap="square" lIns="0" tIns="0" rIns="0" bIns="0" rtlCol="0" anchor="t"/>
+          <a:lstStyle/>
+          <a:p>
+            <a:pPr indent="0" marL="0">
+              <a:buNone/>
+            </a:pPr>
+            <a:r>
+              <a:rPr lang="en-US" sz="1400" dirty="0">
+                <a:solidFill>
+                  <a:srgbClr val="5B6B80"/>
+                </a:solidFill>
+                <a:latin typeface="Calibri" pitchFamily="34" charset="0"/>
+                <a:ea typeface="Calibri" pitchFamily="34" charset="-122"/>
+                <a:cs typeface="Calibri" pitchFamily="34" charset="-120"/>
+              </a:rPr>
+              <a:t>Hires our team and looks after our culture</a:t>
+            </a:r>
+            <a:endParaRPr lang="en-US" sz="1400" dirty="0"/>
+          </a:p>
+        </p:txBody>
+      </p:sp>
+      <p:sp>
+        <p:nvSpPr>
+          <p:cNvPr id="36" name="a11_h"/>
           <p:cNvSpPr txBox="1"/>
           <p:nvPr/>
         </p:nvSpPr>
@@ -2244,7 +2494,7 @@
       </p:sp>
       <p:sp>
         <p:nvSpPr>
-          <p:cNvPr id="30" name="a11_chip"/>
+          <p:cNvPr id="37" name="a12_chip"/>
           <p:cNvSpPr/>
           <p:nvPr/>
         </p:nvSpPr>
@@ -2273,14 +2523,14 @@
       </p:sp>
       <p:pic>
         <p:nvPicPr>
-          <p:cNvPr id="31" name="a11_icon" descr="Training">    </p:cNvPr>
+          <p:cNvPr id="38" name="a12_icon" descr="Training">    </p:cNvPr>
           <p:cNvPicPr>
             <a:picLocks noChangeAspect="1"/>
           </p:cNvPicPr>
           <p:nvPr/>
         </p:nvPicPr>
         <p:blipFill>
-          <a:blip r:embed="rId4"/>
+          <a:blip r:embed="rId8"/>
           <a:stretch>
             <a:fillRect/>
           </a:stretch>
@@ -2297,7 +2547,7 @@
       </p:pic>
       <p:sp>
         <p:nvSpPr>
-          <p:cNvPr id="32" name="a11_t"/>
+          <p:cNvPr id="39" name="a12_t"/>
           <p:cNvSpPr txBox="1"/>
           <p:nvPr/>
         </p:nvSpPr>
@@ -2336,7 +2586,7 @@
       </p:sp>
       <p:sp>
         <p:nvSpPr>
-          <p:cNvPr id="33" name="a12_chip"/>
+          <p:cNvPr id="40" name="a13_chip"/>
           <p:cNvSpPr/>
           <p:nvPr/>
         </p:nvSpPr>
@@ -2365,14 +2615,14 @@
       </p:sp>
       <p:pic>
         <p:nvPicPr>
-          <p:cNvPr id="34" name="a12_icon" descr="Flexible hours">    </p:cNvPr>
+          <p:cNvPr id="41" name="a13_icon" descr="Flexible hours">    </p:cNvPr>
           <p:cNvPicPr>
             <a:picLocks noChangeAspect="1"/>
           </p:cNvPicPr>
           <p:nvPr/>
         </p:nvPicPr>
         <p:blipFill>
-          <a:blip r:embed="rId5"/>
+          <a:blip r:embed="rId9"/>
           <a:stretch>
             <a:fillRect/>
           </a:stretch>
@@ -2389,7 +2639,7 @@
       </p:pic>
       <p:sp>
         <p:nvSpPr>
-          <p:cNvPr id="35" name="a12_t"/>
+          <p:cNvPr id="42" name="a13_t"/>
           <p:cNvSpPr txBox="1"/>
           <p:nvPr/>
         </p:nvSpPr>
@@ -2428,7 +2678,7 @@
       </p:sp>
       <p:sp>
         <p:nvSpPr>
-          <p:cNvPr id="36" name="a13_chip"/>
+          <p:cNvPr id="43" name="a14_chip"/>
           <p:cNvSpPr/>
           <p:nvPr/>
         </p:nvSpPr>
@@ -2457,14 +2707,14 @@
       </p:sp>
       <p:pic>
         <p:nvPicPr>
-          <p:cNvPr id="37" name="a13_icon" descr="Fair pay">    </p:cNvPr>
+          <p:cNvPr id="44" name="a14_icon" descr="Fair pay">    </p:cNvPr>
           <p:cNvPicPr>
             <a:picLocks noChangeAspect="1"/>
           </p:cNvPicPr>
           <p:nvPr/>
         </p:nvPicPr>
         <p:blipFill>
-          <a:blip r:embed="rId6"/>
+          <a:blip r:embed="rId10"/>
           <a:stretch>
             <a:fillRect/>
           </a:stretch>
@@ -2481,7 +2731,7 @@
       </p:pic>
       <p:sp>
         <p:nvSpPr>
-          <p:cNvPr id="38" name="a13_t"/>
+          <p:cNvPr id="45" name="a14_t"/>
           <p:cNvSpPr txBox="1"/>
           <p:nvPr/>
         </p:nvSpPr>
@@ -2520,7 +2770,7 @@
       </p:sp>
       <p:sp>
         <p:nvSpPr>
-          <p:cNvPr id="39" name="a14_chip"/>
+          <p:cNvPr id="46" name="a15_chip"/>
           <p:cNvSpPr/>
           <p:nvPr/>
         </p:nvSpPr>
@@ -2549,14 +2799,14 @@
       </p:sp>
       <p:pic>
         <p:nvPicPr>
-          <p:cNvPr id="40" name="a14_icon" descr="Respect for everyone">    </p:cNvPr>
+          <p:cNvPr id="47" name="a15_icon" descr="Respect for everyone">    </p:cNvPr>
           <p:cNvPicPr>
             <a:picLocks noChangeAspect="1"/>
           </p:cNvPicPr>
           <p:nvPr/>
         </p:nvPicPr>
         <p:blipFill>
-          <a:blip r:embed="rId7"/>
+          <a:blip r:embed="rId11"/>
           <a:stretch>
             <a:fillRect/>
           </a:stretch>
@@ -2573,7 +2823,7 @@
       </p:pic>
       <p:sp>
         <p:nvSpPr>
-          <p:cNvPr id="41" name="a14_t"/>
+          <p:cNvPr id="48" name="a15_t"/>
           <p:cNvSpPr txBox="1"/>
           <p:nvPr/>
         </p:nvSpPr>
@@ -2612,7 +2862,7 @@
       </p:sp>
       <p:sp>
         <p:nvSpPr>
-          <p:cNvPr id="43" name="Text 0"/>
+          <p:cNvPr id="50" name="Text 0"/>
           <p:cNvSpPr/>
           <p:nvPr>
             <p:ph idx="101" type="body" hasCustomPrompt="1"/>
@@ -2702,7 +2952,7 @@
               <p:cTn id="2" dur="indefinite" nodeType="mainSeq">
                 <p:childTnLst>
                   <p:par>
-                    <p:cTn id="208" fill="hold">
+                    <p:cTn id="243" fill="hold">
                       <p:stCondLst>
                         <p:cond delay="indefinite"/>
                         <p:cond evt="onBegin" delay="0">
@@ -2797,7 +3047,7 @@
                                           </p:stCondLst>
                                         </p:cTn>
                                         <p:tgtEl>
-                                          <p:spTgt spid="43"/>
+                                          <p:spTgt spid="50"/>
                                         </p:tgtEl>
                                         <p:attrNameLst>
                                           <p:attrName>style.visibility</p:attrName>
@@ -2811,7 +3061,7 @@
                                       <p:cBhvr>
                                         <p:cTn id="11" dur="600"/>
                                         <p:tgtEl>
-                                          <p:spTgt spid="43"/>
+                                          <p:spTgt spid="50"/>
                                         </p:tgtEl>
                                       </p:cBhvr>
                                     </p:animEffect>
@@ -2819,7 +3069,7 @@
                                       <p:cBhvr>
                                         <p:cTn id="12" dur="600" decel="100000" fill="hold"/>
                                         <p:tgtEl>
-                                          <p:spTgt spid="43"/>
+                                          <p:spTgt spid="50"/>
                                         </p:tgtEl>
                                         <p:attrNameLst>
                                           <p:attrName>ppt_y</p:attrName>
@@ -4191,7 +4441,7 @@
                             </p:stCondLst>
                             <p:childTnLst>
                               <p:par>
-                                <p:cTn id="114" presetID="42" presetClass="entr" presetSubtype="0" fill="hold" grpId="0" nodeType="afterEffect">
+                                <p:cTn id="114" presetID="42" presetClass="entr" presetSubtype="0" fill="hold" grpId="0" nodeType="withEffect">
                                   <p:stCondLst>
                                     <p:cond delay="0"/>
                                   </p:stCondLst>
@@ -4258,7 +4508,7 @@
                             </p:stCondLst>
                             <p:childTnLst>
                               <p:par>
-                                <p:cTn id="119" presetID="42" presetClass="entr" presetSubtype="0" fill="hold" grpId="0" nodeType="withEffect">
+                                <p:cTn id="119" presetID="42" presetClass="entr" presetSubtype="0" fill="hold" grpId="0" nodeType="afterEffect">
                                   <p:stCondLst>
                                     <p:cond delay="0"/>
                                   </p:stCondLst>
@@ -4392,7 +4642,7 @@
                             </p:stCondLst>
                             <p:childTnLst>
                               <p:par>
-                                <p:cTn id="129" presetID="42" presetClass="entr" presetSubtype="0" fill="hold" grpId="0" nodeType="afterEffect">
+                                <p:cTn id="129" presetID="42" presetClass="entr" presetSubtype="0" fill="hold" grpId="0" nodeType="withEffect">
                                   <p:stCondLst>
                                     <p:cond delay="0"/>
                                   </p:stCondLst>
@@ -4526,7 +4776,7 @@
                             </p:stCondLst>
                             <p:childTnLst>
                               <p:par>
-                                <p:cTn id="139" presetID="42" presetClass="entr" presetSubtype="0" fill="hold" grpId="0" nodeType="withEffect">
+                                <p:cTn id="139" presetID="42" presetClass="entr" presetSubtype="0" fill="hold" grpId="0" nodeType="afterEffect">
                                   <p:stCondLst>
                                     <p:cond delay="0"/>
                                   </p:stCondLst>
@@ -4593,7 +4843,7 @@
                             </p:stCondLst>
                             <p:childTnLst>
                               <p:par>
-                                <p:cTn id="144" presetID="42" presetClass="entr" presetSubtype="0" fill="hold" grpId="0" nodeType="afterEffect">
+                                <p:cTn id="144" presetID="42" presetClass="entr" presetSubtype="0" fill="hold" grpId="0" nodeType="withEffect">
                                   <p:stCondLst>
                                     <p:cond delay="0"/>
                                   </p:stCondLst>
@@ -4660,7 +4910,7 @@
                             </p:stCondLst>
                             <p:childTnLst>
                               <p:par>
-                                <p:cTn id="149" presetID="42" presetClass="entr" presetSubtype="0" fill="hold" grpId="0" nodeType="afterEffect">
+                                <p:cTn id="149" presetID="42" presetClass="entr" presetSubtype="0" fill="hold" grpId="0" nodeType="withEffect">
                                   <p:stCondLst>
                                     <p:cond delay="0"/>
                                   </p:stCondLst>
@@ -4794,7 +5044,7 @@
                             </p:stCondLst>
                             <p:childTnLst>
                               <p:par>
-                                <p:cTn id="159" presetID="42" presetClass="entr" presetSubtype="0" fill="hold" grpId="0" nodeType="withEffect">
+                                <p:cTn id="159" presetID="42" presetClass="entr" presetSubtype="0" fill="hold" grpId="0" nodeType="afterEffect">
                                   <p:stCondLst>
                                     <p:cond delay="0"/>
                                   </p:stCondLst>
@@ -4861,7 +5111,7 @@
                             </p:stCondLst>
                             <p:childTnLst>
                               <p:par>
-                                <p:cTn id="164" presetID="42" presetClass="entr" presetSubtype="0" fill="hold" grpId="0" nodeType="afterEffect">
+                                <p:cTn id="164" presetID="42" presetClass="entr" presetSubtype="0" fill="hold" grpId="0" nodeType="withEffect">
                                   <p:stCondLst>
                                     <p:cond delay="0"/>
                                   </p:stCondLst>
@@ -5129,7 +5379,7 @@
                             </p:stCondLst>
                             <p:childTnLst>
                               <p:par>
-                                <p:cTn id="184" presetID="42" presetClass="entr" presetSubtype="0" fill="hold" grpId="0" nodeType="withEffect">
+                                <p:cTn id="184" presetID="42" presetClass="entr" presetSubtype="0" fill="hold" grpId="0" nodeType="afterEffect">
                                   <p:stCondLst>
                                     <p:cond delay="0"/>
                                   </p:stCondLst>
@@ -5263,7 +5513,7 @@
                             </p:stCondLst>
                             <p:childTnLst>
                               <p:par>
-                                <p:cTn id="194" presetID="42" presetClass="entr" presetSubtype="0" fill="hold" grpId="0" nodeType="afterEffect">
+                                <p:cTn id="194" presetID="42" presetClass="entr" presetSubtype="0" fill="hold" grpId="0" nodeType="withEffect">
                                   <p:stCondLst>
                                     <p:cond delay="0"/>
                                   </p:stCondLst>
@@ -5330,7 +5580,7 @@
                             </p:stCondLst>
                             <p:childTnLst>
                               <p:par>
-                                <p:cTn id="199" presetID="42" presetClass="entr" presetSubtype="0" fill="hold" grpId="0" nodeType="withEffect">
+                                <p:cTn id="199" presetID="42" presetClass="entr" presetSubtype="0" fill="hold" grpId="0" nodeType="afterEffect">
                                   <p:stCondLst>
                                     <p:cond delay="0"/>
                                   </p:stCondLst>
@@ -5433,6 +5683,475 @@
                                         <p:cTn id="207" dur="600" decel="100000" fill="hold"/>
                                         <p:tgtEl>
                                           <p:spTgt spid="41"/>
+                                        </p:tgtEl>
+                                        <p:attrNameLst>
+                                          <p:attrName>ppt_y</p:attrName>
+                                        </p:attrNameLst>
+                                      </p:cBhvr>
+                                      <p:tavLst>
+                                        <p:tav tm="0">
+                                          <p:val>
+                                            <p:strVal val="#ppt_y+0.04"/>
+                                          </p:val>
+                                        </p:tav>
+                                        <p:tav tm="100000">
+                                          <p:val>
+                                            <p:strVal val="#ppt_y"/>
+                                          </p:val>
+                                        </p:tav>
+                                      </p:tavLst>
+                                    </p:anim>
+                                  </p:childTnLst>
+                                </p:cTn>
+                              </p:par>
+                            </p:childTnLst>
+                          </p:cTn>
+                        </p:par>
+                        <p:par>
+                          <p:cTn id="208" fill="hold">
+                            <p:stCondLst>
+                              <p:cond delay="0"/>
+                            </p:stCondLst>
+                            <p:childTnLst>
+                              <p:par>
+                                <p:cTn id="209" presetID="42" presetClass="entr" presetSubtype="0" fill="hold" grpId="0" nodeType="withEffect">
+                                  <p:stCondLst>
+                                    <p:cond delay="0"/>
+                                  </p:stCondLst>
+                                  <p:childTnLst>
+                                    <p:set>
+                                      <p:cBhvr>
+                                        <p:cTn id="210" dur="1" fill="hold">
+                                          <p:stCondLst>
+                                            <p:cond delay="0"/>
+                                          </p:stCondLst>
+                                        </p:cTn>
+                                        <p:tgtEl>
+                                          <p:spTgt spid="42"/>
+                                        </p:tgtEl>
+                                        <p:attrNameLst>
+                                          <p:attrName>style.visibility</p:attrName>
+                                        </p:attrNameLst>
+                                      </p:cBhvr>
+                                      <p:to>
+                                        <p:strVal val="visible"/>
+                                      </p:to>
+                                    </p:set>
+                                    <p:animEffect transition="in" filter="fade">
+                                      <p:cBhvr>
+                                        <p:cTn id="211" dur="600"/>
+                                        <p:tgtEl>
+                                          <p:spTgt spid="42"/>
+                                        </p:tgtEl>
+                                      </p:cBhvr>
+                                    </p:animEffect>
+                                    <p:anim calcmode="lin" valueType="num">
+                                      <p:cBhvr>
+                                        <p:cTn id="212" dur="600" decel="100000" fill="hold"/>
+                                        <p:tgtEl>
+                                          <p:spTgt spid="42"/>
+                                        </p:tgtEl>
+                                        <p:attrNameLst>
+                                          <p:attrName>ppt_y</p:attrName>
+                                        </p:attrNameLst>
+                                      </p:cBhvr>
+                                      <p:tavLst>
+                                        <p:tav tm="0">
+                                          <p:val>
+                                            <p:strVal val="#ppt_y+0.04"/>
+                                          </p:val>
+                                        </p:tav>
+                                        <p:tav tm="100000">
+                                          <p:val>
+                                            <p:strVal val="#ppt_y"/>
+                                          </p:val>
+                                        </p:tav>
+                                      </p:tavLst>
+                                    </p:anim>
+                                  </p:childTnLst>
+                                </p:cTn>
+                              </p:par>
+                            </p:childTnLst>
+                          </p:cTn>
+                        </p:par>
+                        <p:par>
+                          <p:cTn id="213" fill="hold">
+                            <p:stCondLst>
+                              <p:cond delay="0"/>
+                            </p:stCondLst>
+                            <p:childTnLst>
+                              <p:par>
+                                <p:cTn id="214" presetID="42" presetClass="entr" presetSubtype="0" fill="hold" grpId="0" nodeType="afterEffect">
+                                  <p:stCondLst>
+                                    <p:cond delay="0"/>
+                                  </p:stCondLst>
+                                  <p:childTnLst>
+                                    <p:set>
+                                      <p:cBhvr>
+                                        <p:cTn id="215" dur="1" fill="hold">
+                                          <p:stCondLst>
+                                            <p:cond delay="0"/>
+                                          </p:stCondLst>
+                                        </p:cTn>
+                                        <p:tgtEl>
+                                          <p:spTgt spid="43"/>
+                                        </p:tgtEl>
+                                        <p:attrNameLst>
+                                          <p:attrName>style.visibility</p:attrName>
+                                        </p:attrNameLst>
+                                      </p:cBhvr>
+                                      <p:to>
+                                        <p:strVal val="visible"/>
+                                      </p:to>
+                                    </p:set>
+                                    <p:animEffect transition="in" filter="fade">
+                                      <p:cBhvr>
+                                        <p:cTn id="216" dur="600"/>
+                                        <p:tgtEl>
+                                          <p:spTgt spid="43"/>
+                                        </p:tgtEl>
+                                      </p:cBhvr>
+                                    </p:animEffect>
+                                    <p:anim calcmode="lin" valueType="num">
+                                      <p:cBhvr>
+                                        <p:cTn id="217" dur="600" decel="100000" fill="hold"/>
+                                        <p:tgtEl>
+                                          <p:spTgt spid="43"/>
+                                        </p:tgtEl>
+                                        <p:attrNameLst>
+                                          <p:attrName>ppt_y</p:attrName>
+                                        </p:attrNameLst>
+                                      </p:cBhvr>
+                                      <p:tavLst>
+                                        <p:tav tm="0">
+                                          <p:val>
+                                            <p:strVal val="#ppt_y+0.04"/>
+                                          </p:val>
+                                        </p:tav>
+                                        <p:tav tm="100000">
+                                          <p:val>
+                                            <p:strVal val="#ppt_y"/>
+                                          </p:val>
+                                        </p:tav>
+                                      </p:tavLst>
+                                    </p:anim>
+                                  </p:childTnLst>
+                                </p:cTn>
+                              </p:par>
+                            </p:childTnLst>
+                          </p:cTn>
+                        </p:par>
+                        <p:par>
+                          <p:cTn id="218" fill="hold">
+                            <p:stCondLst>
+                              <p:cond delay="0"/>
+                            </p:stCondLst>
+                            <p:childTnLst>
+                              <p:par>
+                                <p:cTn id="219" presetID="42" presetClass="entr" presetSubtype="0" fill="hold" grpId="0" nodeType="withEffect">
+                                  <p:stCondLst>
+                                    <p:cond delay="0"/>
+                                  </p:stCondLst>
+                                  <p:childTnLst>
+                                    <p:set>
+                                      <p:cBhvr>
+                                        <p:cTn id="220" dur="1" fill="hold">
+                                          <p:stCondLst>
+                                            <p:cond delay="0"/>
+                                          </p:stCondLst>
+                                        </p:cTn>
+                                        <p:tgtEl>
+                                          <p:spTgt spid="44"/>
+                                        </p:tgtEl>
+                                        <p:attrNameLst>
+                                          <p:attrName>style.visibility</p:attrName>
+                                        </p:attrNameLst>
+                                      </p:cBhvr>
+                                      <p:to>
+                                        <p:strVal val="visible"/>
+                                      </p:to>
+                                    </p:set>
+                                    <p:animEffect transition="in" filter="fade">
+                                      <p:cBhvr>
+                                        <p:cTn id="221" dur="600"/>
+                                        <p:tgtEl>
+                                          <p:spTgt spid="44"/>
+                                        </p:tgtEl>
+                                      </p:cBhvr>
+                                    </p:animEffect>
+                                    <p:anim calcmode="lin" valueType="num">
+                                      <p:cBhvr>
+                                        <p:cTn id="222" dur="600" decel="100000" fill="hold"/>
+                                        <p:tgtEl>
+                                          <p:spTgt spid="44"/>
+                                        </p:tgtEl>
+                                        <p:attrNameLst>
+                                          <p:attrName>ppt_y</p:attrName>
+                                        </p:attrNameLst>
+                                      </p:cBhvr>
+                                      <p:tavLst>
+                                        <p:tav tm="0">
+                                          <p:val>
+                                            <p:strVal val="#ppt_y+0.04"/>
+                                          </p:val>
+                                        </p:tav>
+                                        <p:tav tm="100000">
+                                          <p:val>
+                                            <p:strVal val="#ppt_y"/>
+                                          </p:val>
+                                        </p:tav>
+                                      </p:tavLst>
+                                    </p:anim>
+                                  </p:childTnLst>
+                                </p:cTn>
+                              </p:par>
+                            </p:childTnLst>
+                          </p:cTn>
+                        </p:par>
+                        <p:par>
+                          <p:cTn id="223" fill="hold">
+                            <p:stCondLst>
+                              <p:cond delay="0"/>
+                            </p:stCondLst>
+                            <p:childTnLst>
+                              <p:par>
+                                <p:cTn id="224" presetID="42" presetClass="entr" presetSubtype="0" fill="hold" grpId="0" nodeType="withEffect">
+                                  <p:stCondLst>
+                                    <p:cond delay="0"/>
+                                  </p:stCondLst>
+                                  <p:childTnLst>
+                                    <p:set>
+                                      <p:cBhvr>
+                                        <p:cTn id="225" dur="1" fill="hold">
+                                          <p:stCondLst>
+                                            <p:cond delay="0"/>
+                                          </p:stCondLst>
+                                        </p:cTn>
+                                        <p:tgtEl>
+                                          <p:spTgt spid="45"/>
+                                        </p:tgtEl>
+                                        <p:attrNameLst>
+                                          <p:attrName>style.visibility</p:attrName>
+                                        </p:attrNameLst>
+                                      </p:cBhvr>
+                                      <p:to>
+                                        <p:strVal val="visible"/>
+                                      </p:to>
+                                    </p:set>
+                                    <p:animEffect transition="in" filter="fade">
+                                      <p:cBhvr>
+                                        <p:cTn id="226" dur="600"/>
+                                        <p:tgtEl>
+                                          <p:spTgt spid="45"/>
+                                        </p:tgtEl>
+                                      </p:cBhvr>
+                                    </p:animEffect>
+                                    <p:anim calcmode="lin" valueType="num">
+                                      <p:cBhvr>
+                                        <p:cTn id="227" dur="600" decel="100000" fill="hold"/>
+                                        <p:tgtEl>
+                                          <p:spTgt spid="45"/>
+                                        </p:tgtEl>
+                                        <p:attrNameLst>
+                                          <p:attrName>ppt_y</p:attrName>
+                                        </p:attrNameLst>
+                                      </p:cBhvr>
+                                      <p:tavLst>
+                                        <p:tav tm="0">
+                                          <p:val>
+                                            <p:strVal val="#ppt_y+0.04"/>
+                                          </p:val>
+                                        </p:tav>
+                                        <p:tav tm="100000">
+                                          <p:val>
+                                            <p:strVal val="#ppt_y"/>
+                                          </p:val>
+                                        </p:tav>
+                                      </p:tavLst>
+                                    </p:anim>
+                                  </p:childTnLst>
+                                </p:cTn>
+                              </p:par>
+                            </p:childTnLst>
+                          </p:cTn>
+                        </p:par>
+                        <p:par>
+                          <p:cTn id="228" fill="hold">
+                            <p:stCondLst>
+                              <p:cond delay="0"/>
+                            </p:stCondLst>
+                            <p:childTnLst>
+                              <p:par>
+                                <p:cTn id="229" presetID="42" presetClass="entr" presetSubtype="0" fill="hold" grpId="0" nodeType="afterEffect">
+                                  <p:stCondLst>
+                                    <p:cond delay="0"/>
+                                  </p:stCondLst>
+                                  <p:childTnLst>
+                                    <p:set>
+                                      <p:cBhvr>
+                                        <p:cTn id="230" dur="1" fill="hold">
+                                          <p:stCondLst>
+                                            <p:cond delay="0"/>
+                                          </p:stCondLst>
+                                        </p:cTn>
+                                        <p:tgtEl>
+                                          <p:spTgt spid="46"/>
+                                        </p:tgtEl>
+                                        <p:attrNameLst>
+                                          <p:attrName>style.visibility</p:attrName>
+                                        </p:attrNameLst>
+                                      </p:cBhvr>
+                                      <p:to>
+                                        <p:strVal val="visible"/>
+                                      </p:to>
+                                    </p:set>
+                                    <p:animEffect transition="in" filter="fade">
+                                      <p:cBhvr>
+                                        <p:cTn id="231" dur="600"/>
+                                        <p:tgtEl>
+                                          <p:spTgt spid="46"/>
+                                        </p:tgtEl>
+                                      </p:cBhvr>
+                                    </p:animEffect>
+                                    <p:anim calcmode="lin" valueType="num">
+                                      <p:cBhvr>
+                                        <p:cTn id="232" dur="600" decel="100000" fill="hold"/>
+                                        <p:tgtEl>
+                                          <p:spTgt spid="46"/>
+                                        </p:tgtEl>
+                                        <p:attrNameLst>
+                                          <p:attrName>ppt_y</p:attrName>
+                                        </p:attrNameLst>
+                                      </p:cBhvr>
+                                      <p:tavLst>
+                                        <p:tav tm="0">
+                                          <p:val>
+                                            <p:strVal val="#ppt_y+0.04"/>
+                                          </p:val>
+                                        </p:tav>
+                                        <p:tav tm="100000">
+                                          <p:val>
+                                            <p:strVal val="#ppt_y"/>
+                                          </p:val>
+                                        </p:tav>
+                                      </p:tavLst>
+                                    </p:anim>
+                                  </p:childTnLst>
+                                </p:cTn>
+                              </p:par>
+                            </p:childTnLst>
+                          </p:cTn>
+                        </p:par>
+                        <p:par>
+                          <p:cTn id="233" fill="hold">
+                            <p:stCondLst>
+                              <p:cond delay="0"/>
+                            </p:stCondLst>
+                            <p:childTnLst>
+                              <p:par>
+                                <p:cTn id="234" presetID="42" presetClass="entr" presetSubtype="0" fill="hold" grpId="0" nodeType="withEffect">
+                                  <p:stCondLst>
+                                    <p:cond delay="0"/>
+                                  </p:stCondLst>
+                                  <p:childTnLst>
+                                    <p:set>
+                                      <p:cBhvr>
+                                        <p:cTn id="235" dur="1" fill="hold">
+                                          <p:stCondLst>
+                                            <p:cond delay="0"/>
+                                          </p:stCondLst>
+                                        </p:cTn>
+                                        <p:tgtEl>
+                                          <p:spTgt spid="47"/>
+                                        </p:tgtEl>
+                                        <p:attrNameLst>
+                                          <p:attrName>style.visibility</p:attrName>
+                                        </p:attrNameLst>
+                                      </p:cBhvr>
+                                      <p:to>
+                                        <p:strVal val="visible"/>
+                                      </p:to>
+                                    </p:set>
+                                    <p:animEffect transition="in" filter="fade">
+                                      <p:cBhvr>
+                                        <p:cTn id="236" dur="600"/>
+                                        <p:tgtEl>
+                                          <p:spTgt spid="47"/>
+                                        </p:tgtEl>
+                                      </p:cBhvr>
+                                    </p:animEffect>
+                                    <p:anim calcmode="lin" valueType="num">
+                                      <p:cBhvr>
+                                        <p:cTn id="237" dur="600" decel="100000" fill="hold"/>
+                                        <p:tgtEl>
+                                          <p:spTgt spid="47"/>
+                                        </p:tgtEl>
+                                        <p:attrNameLst>
+                                          <p:attrName>ppt_y</p:attrName>
+                                        </p:attrNameLst>
+                                      </p:cBhvr>
+                                      <p:tavLst>
+                                        <p:tav tm="0">
+                                          <p:val>
+                                            <p:strVal val="#ppt_y+0.04"/>
+                                          </p:val>
+                                        </p:tav>
+                                        <p:tav tm="100000">
+                                          <p:val>
+                                            <p:strVal val="#ppt_y"/>
+                                          </p:val>
+                                        </p:tav>
+                                      </p:tavLst>
+                                    </p:anim>
+                                  </p:childTnLst>
+                                </p:cTn>
+                              </p:par>
+                            </p:childTnLst>
+                          </p:cTn>
+                        </p:par>
+                        <p:par>
+                          <p:cTn id="238" fill="hold">
+                            <p:stCondLst>
+                              <p:cond delay="0"/>
+                            </p:stCondLst>
+                            <p:childTnLst>
+                              <p:par>
+                                <p:cTn id="239" presetID="42" presetClass="entr" presetSubtype="0" fill="hold" grpId="0" nodeType="withEffect">
+                                  <p:stCondLst>
+                                    <p:cond delay="0"/>
+                                  </p:stCondLst>
+                                  <p:childTnLst>
+                                    <p:set>
+                                      <p:cBhvr>
+                                        <p:cTn id="240" dur="1" fill="hold">
+                                          <p:stCondLst>
+                                            <p:cond delay="0"/>
+                                          </p:stCondLst>
+                                        </p:cTn>
+                                        <p:tgtEl>
+                                          <p:spTgt spid="48"/>
+                                        </p:tgtEl>
+                                        <p:attrNameLst>
+                                          <p:attrName>style.visibility</p:attrName>
+                                        </p:attrNameLst>
+                                      </p:cBhvr>
+                                      <p:to>
+                                        <p:strVal val="visible"/>
+                                      </p:to>
+                                    </p:set>
+                                    <p:animEffect transition="in" filter="fade">
+                                      <p:cBhvr>
+                                        <p:cTn id="241" dur="600"/>
+                                        <p:tgtEl>
+                                          <p:spTgt spid="48"/>
+                                        </p:tgtEl>
+                                      </p:cBhvr>
+                                    </p:animEffect>
+                                    <p:anim calcmode="lin" valueType="num">
+                                      <p:cBhvr>
+                                        <p:cTn id="242" dur="600" decel="100000" fill="hold"/>
+                                        <p:tgtEl>
+                                          <p:spTgt spid="48"/>
                                         </p:tgtEl>
                                         <p:attrNameLst>
                                           <p:attrName>ppt_y</p:attrName>
@@ -5483,7 +6202,7 @@
     </p:tnLst>
     <p:bldLst>
       <p:bldP spid="2" grpId="0" animBg="1"/>
-      <p:bldP spid="43" grpId="0" animBg="1"/>
+      <p:bldP spid="50" grpId="0" animBg="1"/>
       <p:bldP spid="3" grpId="0" animBg="1"/>
       <p:bldP spid="4" grpId="0" animBg="1"/>
       <p:bldP spid="5" grpId="0" animBg="1"/>
@@ -5499,23 +6218,26 @@
       <p:bldP spid="18" grpId="0" animBg="1"/>
       <p:bldP spid="19" grpId="0" animBg="1"/>
       <p:bldP spid="20" grpId="0" animBg="1"/>
-      <p:bldP spid="21" grpId="0" animBg="1"/>
       <p:bldP spid="22" grpId="0" animBg="1"/>
       <p:bldP spid="23" grpId="0" animBg="1"/>
       <p:bldP spid="24" grpId="0" animBg="1"/>
-      <p:bldP spid="25" grpId="0" animBg="1"/>
       <p:bldP spid="26" grpId="0" animBg="1"/>
       <p:bldP spid="27" grpId="0" animBg="1"/>
       <p:bldP spid="28" grpId="0" animBg="1"/>
-      <p:bldP spid="29" grpId="0" animBg="1"/>
       <p:bldP spid="30" grpId="0" animBg="1"/>
+      <p:bldP spid="31" grpId="0" animBg="1"/>
       <p:bldP spid="32" grpId="0" animBg="1"/>
-      <p:bldP spid="33" grpId="0" animBg="1"/>
+      <p:bldP spid="34" grpId="0" animBg="1"/>
       <p:bldP spid="35" grpId="0" animBg="1"/>
       <p:bldP spid="36" grpId="0" animBg="1"/>
-      <p:bldP spid="38" grpId="0" animBg="1"/>
+      <p:bldP spid="37" grpId="0" animBg="1"/>
       <p:bldP spid="39" grpId="0" animBg="1"/>
-      <p:bldP spid="41" grpId="0" animBg="1"/>
+      <p:bldP spid="40" grpId="0" animBg="1"/>
+      <p:bldP spid="42" grpId="0" animBg="1"/>
+      <p:bldP spid="43" grpId="0" animBg="1"/>
+      <p:bldP spid="45" grpId="0" animBg="1"/>
+      <p:bldP spid="46" grpId="0" animBg="1"/>
+      <p:bldP spid="48" grpId="0" animBg="1"/>
     </p:bldLst>
   </p:timing>
 </p:sld>

</xml_diff>